<commit_message>
pptx: rework slide 3, drop live-update claim
- Slide 3: real CSV-link input + "Загрузить" + browser window with
  dashboard instead of the fake spreadsheet mockup.
- Remove "дописываете по ходу гонки — обновляется сам": app does not
  compute places, so live framing was misleading. Now: edit the sheet,
  reload the dashboard.

Co-Authored-By: Claude Opus 4.8 <noreply@anthropic.com>
</commit_message>
<xml_diff>
--- a/Racelytics.pptx
+++ b/Racelytics.pptx
@@ -3628,7 +3628,7 @@
         <p:spPr>
           <a:xfrm>
             <a:off x="868680" y="1042416"/>
-            <a:ext cx="10881360" cy="457200"/>
+            <a:ext cx="10927080" cy="457200"/>
           </a:xfrm>
           <a:prstGeom prst="rect">
             <a:avLst/>
@@ -4411,7 +4411,7 @@
         <p:spPr>
           <a:xfrm>
             <a:off x="868680" y="1042416"/>
-            <a:ext cx="10881360" cy="457200"/>
+            <a:ext cx="10927080" cy="457200"/>
           </a:xfrm>
           <a:prstGeom prst="rect">
             <a:avLst/>
@@ -4449,12 +4449,12 @@
         </p:nvSpPr>
         <p:spPr>
           <a:xfrm>
-            <a:off x="1051560" y="1874519"/>
-            <a:ext cx="3977639" cy="2331720"/>
+            <a:off x="566928" y="1783080"/>
+            <a:ext cx="4937760" cy="2743200"/>
           </a:xfrm>
           <a:prstGeom prst="roundRect">
             <a:avLst>
-              <a:gd name="adj" fmla="val 5000"/>
+              <a:gd name="adj" fmla="val 4000"/>
             </a:avLst>
           </a:prstGeom>
           <a:solidFill>
@@ -4497,8 +4497,8 @@
         </p:nvSpPr>
         <p:spPr>
           <a:xfrm>
-            <a:off x="1417319" y="2167127"/>
-            <a:ext cx="3246120" cy="457200"/>
+            <a:off x="950976" y="2112264"/>
+            <a:ext cx="4169664" cy="274320"/>
           </a:xfrm>
           <a:prstGeom prst="rect">
             <a:avLst/>
@@ -4513,27 +4513,191 @@
           <a:p>
             <a:pPr algn="l"/>
             <a:r>
-              <a:rPr sz="1900" b="1" i="0">
-                <a:solidFill>
-                  <a:srgbClr val="17201C"/>
+              <a:rPr sz="1100" b="1" i="0">
+                <a:solidFill>
+                  <a:srgbClr val="68736D"/>
+                </a:solidFill>
+                <a:latin typeface="Calibri"/>
+              </a:rPr>
+              <a:t>ССЫЛКА НА CSV-ФАЙЛ</a:t>
+            </a:r>
+          </a:p>
+        </p:txBody>
+      </p:sp>
+      <p:sp>
+        <p:nvSpPr>
+          <p:cNvPr id="8" name="Rounded Rectangle 7"/>
+          <p:cNvSpPr/>
+          <p:nvPr/>
+        </p:nvSpPr>
+        <p:spPr>
+          <a:xfrm>
+            <a:off x="950976" y="2496312"/>
+            <a:ext cx="2651760" cy="566928"/>
+          </a:xfrm>
+          <a:prstGeom prst="roundRect">
+            <a:avLst>
+              <a:gd name="adj" fmla="val 12000"/>
+            </a:avLst>
+          </a:prstGeom>
+          <a:solidFill>
+            <a:srgbClr val="FFFFFF"/>
+          </a:solidFill>
+          <a:ln w="16510">
+            <a:solidFill>
+              <a:srgbClr val="C9D2CC"/>
+            </a:solidFill>
+          </a:ln>
+          <a:effectLst/>
+        </p:spPr>
+        <p:style>
+          <a:lnRef idx="1">
+            <a:schemeClr val="accent1"/>
+          </a:lnRef>
+          <a:fillRef idx="3">
+            <a:schemeClr val="accent1"/>
+          </a:fillRef>
+          <a:effectRef idx="2">
+            <a:schemeClr val="accent1"/>
+          </a:effectRef>
+          <a:fontRef idx="minor">
+            <a:schemeClr val="lt1"/>
+          </a:fontRef>
+        </p:style>
+        <p:txBody>
+          <a:bodyPr rtlCol="0" anchor="ctr"/>
+          <a:lstStyle/>
+          <a:p>
+            <a:pPr algn="ctr"/>
+          </a:p>
+        </p:txBody>
+      </p:sp>
+      <p:sp>
+        <p:nvSpPr>
+          <p:cNvPr id="9" name="TextBox 8"/>
+          <p:cNvSpPr txBox="1"/>
+          <p:nvPr/>
+        </p:nvSpPr>
+        <p:spPr>
+          <a:xfrm>
+            <a:off x="1097280" y="2496312"/>
+            <a:ext cx="2395728" cy="566928"/>
+          </a:xfrm>
+          <a:prstGeom prst="rect">
+            <a:avLst/>
+          </a:prstGeom>
+          <a:noFill/>
+        </p:spPr>
+        <p:txBody>
+          <a:bodyPr wrap="square" anchor="ctr" lIns="0" rIns="0" tIns="0" bIns="0">
+            <a:spAutoFit/>
+          </a:bodyPr>
+          <a:lstStyle/>
+          <a:p>
+            <a:pPr algn="l"/>
+            <a:r>
+              <a:rPr sz="1100" b="0" i="0">
+                <a:solidFill>
+                  <a:srgbClr val="55605A"/>
+                </a:solidFill>
+                <a:latin typeface="Calibri"/>
+              </a:rPr>
+              <a:t>docs.google.com/…/output=csv</a:t>
+            </a:r>
+          </a:p>
+        </p:txBody>
+      </p:sp>
+      <p:sp>
+        <p:nvSpPr>
+          <p:cNvPr id="10" name="Rounded Rectangle 9"/>
+          <p:cNvSpPr/>
+          <p:nvPr/>
+        </p:nvSpPr>
+        <p:spPr>
+          <a:xfrm>
+            <a:off x="3749040" y="2496312"/>
+            <a:ext cx="1371600" cy="566928"/>
+          </a:xfrm>
+          <a:prstGeom prst="roundRect">
+            <a:avLst>
+              <a:gd name="adj" fmla="val 12000"/>
+            </a:avLst>
+          </a:prstGeom>
+          <a:solidFill>
+            <a:srgbClr val="293241"/>
+          </a:solidFill>
+          <a:ln>
+            <a:noFill/>
+          </a:ln>
+          <a:effectLst/>
+        </p:spPr>
+        <p:style>
+          <a:lnRef idx="1">
+            <a:schemeClr val="accent1"/>
+          </a:lnRef>
+          <a:fillRef idx="3">
+            <a:schemeClr val="accent1"/>
+          </a:fillRef>
+          <a:effectRef idx="2">
+            <a:schemeClr val="accent1"/>
+          </a:effectRef>
+          <a:fontRef idx="minor">
+            <a:schemeClr val="lt1"/>
+          </a:fontRef>
+        </p:style>
+        <p:txBody>
+          <a:bodyPr rtlCol="0" anchor="ctr"/>
+          <a:lstStyle/>
+          <a:p>
+            <a:pPr algn="ctr"/>
+          </a:p>
+        </p:txBody>
+      </p:sp>
+      <p:sp>
+        <p:nvSpPr>
+          <p:cNvPr id="11" name="TextBox 10"/>
+          <p:cNvSpPr txBox="1"/>
+          <p:nvPr/>
+        </p:nvSpPr>
+        <p:spPr>
+          <a:xfrm>
+            <a:off x="3749040" y="2496312"/>
+            <a:ext cx="1371600" cy="566928"/>
+          </a:xfrm>
+          <a:prstGeom prst="rect">
+            <a:avLst/>
+          </a:prstGeom>
+          <a:noFill/>
+        </p:spPr>
+        <p:txBody>
+          <a:bodyPr wrap="square" anchor="ctr" lIns="0" rIns="0" tIns="0" bIns="0">
+            <a:spAutoFit/>
+          </a:bodyPr>
+          <a:lstStyle/>
+          <a:p>
+            <a:pPr algn="ctr"/>
+            <a:r>
+              <a:rPr sz="1300" b="1" i="0">
+                <a:solidFill>
+                  <a:srgbClr val="FFFFFF"/>
                 </a:solidFill>
                 <a:latin typeface="Trebuchet MS"/>
               </a:rPr>
-              <a:t>Google Таблица</a:t>
-            </a:r>
-          </a:p>
-        </p:txBody>
-      </p:sp>
-      <p:sp>
-        <p:nvSpPr>
-          <p:cNvPr id="8" name="TextBox 7"/>
+              <a:t>Загрузить</a:t>
+            </a:r>
+          </a:p>
+        </p:txBody>
+      </p:sp>
+      <p:sp>
+        <p:nvSpPr>
+          <p:cNvPr id="12" name="TextBox 11"/>
           <p:cNvSpPr txBox="1"/>
           <p:nvPr/>
         </p:nvSpPr>
         <p:spPr>
           <a:xfrm>
-            <a:off x="1417319" y="2642615"/>
-            <a:ext cx="3246120" cy="320040"/>
+            <a:off x="950976" y="3374136"/>
+            <a:ext cx="4169664" cy="914400"/>
           </a:xfrm>
           <a:prstGeom prst="rect">
             <a:avLst/>
@@ -4546,31 +4710,171 @@
           </a:bodyPr>
           <a:lstStyle/>
           <a:p>
-            <a:pPr algn="l"/>
-            <a:r>
-              <a:rPr sz="1300" b="0" i="0">
-                <a:solidFill>
-                  <a:srgbClr val="68736D"/>
+            <a:pPr algn="l">
+              <a:lnSpc>
+                <a:spcPct val="120000"/>
+              </a:lnSpc>
+            </a:pPr>
+            <a:r>
+              <a:rPr sz="1350" b="0" i="0">
+                <a:solidFill>
+                  <a:srgbClr val="434D47"/>
                 </a:solidFill>
                 <a:latin typeface="Calibri"/>
               </a:rPr>
-              <a:t>ваш привычный протокол</a:t>
-            </a:r>
-          </a:p>
-        </p:txBody>
-      </p:sp>
-      <p:sp>
-        <p:nvSpPr>
-          <p:cNvPr id="9" name="Rectangle 8"/>
+              <a:t>Берёте опубликованную CSV-ссылку из Google Таблиц и вставляете в это поле. Один раз — дальше она работает всегда.</a:t>
+            </a:r>
+          </a:p>
+        </p:txBody>
+      </p:sp>
+      <p:sp>
+        <p:nvSpPr>
+          <p:cNvPr id="13" name="Rounded Rectangle 12"/>
           <p:cNvSpPr/>
           <p:nvPr/>
         </p:nvSpPr>
         <p:spPr>
           <a:xfrm>
-            <a:off x="1417319" y="3108960"/>
-            <a:ext cx="3246120" cy="310896"/>
-          </a:xfrm>
-          <a:prstGeom prst="rect">
+            <a:off x="6684264" y="1783080"/>
+            <a:ext cx="4937760" cy="2743200"/>
+          </a:xfrm>
+          <a:prstGeom prst="roundRect">
+            <a:avLst>
+              <a:gd name="adj" fmla="val 4000"/>
+            </a:avLst>
+          </a:prstGeom>
+          <a:solidFill>
+            <a:srgbClr val="FFFFFF"/>
+          </a:solidFill>
+          <a:ln w="16510">
+            <a:solidFill>
+              <a:srgbClr val="DCE3DD"/>
+            </a:solidFill>
+          </a:ln>
+          <a:effectLst/>
+        </p:spPr>
+        <p:style>
+          <a:lnRef idx="1">
+            <a:schemeClr val="accent1"/>
+          </a:lnRef>
+          <a:fillRef idx="3">
+            <a:schemeClr val="accent1"/>
+          </a:fillRef>
+          <a:effectRef idx="2">
+            <a:schemeClr val="accent1"/>
+          </a:effectRef>
+          <a:fontRef idx="minor">
+            <a:schemeClr val="lt1"/>
+          </a:fontRef>
+        </p:style>
+        <p:txBody>
+          <a:bodyPr rtlCol="0" anchor="ctr"/>
+          <a:lstStyle/>
+          <a:p>
+            <a:pPr algn="ctr"/>
+          </a:p>
+        </p:txBody>
+      </p:sp>
+      <p:sp>
+        <p:nvSpPr>
+          <p:cNvPr id="14" name="Oval 13"/>
+          <p:cNvSpPr/>
+          <p:nvPr/>
+        </p:nvSpPr>
+        <p:spPr>
+          <a:xfrm>
+            <a:off x="6995159" y="2029967"/>
+            <a:ext cx="137160" cy="137160"/>
+          </a:xfrm>
+          <a:prstGeom prst="ellipse">
+            <a:avLst/>
+          </a:prstGeom>
+          <a:solidFill>
+            <a:srgbClr val="B3261E"/>
+          </a:solidFill>
+          <a:ln>
+            <a:noFill/>
+          </a:ln>
+          <a:effectLst/>
+        </p:spPr>
+        <p:style>
+          <a:lnRef idx="1">
+            <a:schemeClr val="accent1"/>
+          </a:lnRef>
+          <a:fillRef idx="3">
+            <a:schemeClr val="accent1"/>
+          </a:fillRef>
+          <a:effectRef idx="2">
+            <a:schemeClr val="accent1"/>
+          </a:effectRef>
+          <a:fontRef idx="minor">
+            <a:schemeClr val="lt1"/>
+          </a:fontRef>
+        </p:style>
+        <p:txBody>
+          <a:bodyPr rtlCol="0" anchor="ctr"/>
+          <a:lstStyle/>
+          <a:p>
+            <a:pPr algn="ctr"/>
+          </a:p>
+        </p:txBody>
+      </p:sp>
+      <p:sp>
+        <p:nvSpPr>
+          <p:cNvPr id="15" name="Oval 14"/>
+          <p:cNvSpPr/>
+          <p:nvPr/>
+        </p:nvSpPr>
+        <p:spPr>
+          <a:xfrm>
+            <a:off x="7269479" y="2029967"/>
+            <a:ext cx="137160" cy="137160"/>
+          </a:xfrm>
+          <a:prstGeom prst="ellipse">
+            <a:avLst/>
+          </a:prstGeom>
+          <a:solidFill>
+            <a:srgbClr val="D69E2E"/>
+          </a:solidFill>
+          <a:ln>
+            <a:noFill/>
+          </a:ln>
+          <a:effectLst/>
+        </p:spPr>
+        <p:style>
+          <a:lnRef idx="1">
+            <a:schemeClr val="accent1"/>
+          </a:lnRef>
+          <a:fillRef idx="3">
+            <a:schemeClr val="accent1"/>
+          </a:fillRef>
+          <a:effectRef idx="2">
+            <a:schemeClr val="accent1"/>
+          </a:effectRef>
+          <a:fontRef idx="minor">
+            <a:schemeClr val="lt1"/>
+          </a:fontRef>
+        </p:style>
+        <p:txBody>
+          <a:bodyPr rtlCol="0" anchor="ctr"/>
+          <a:lstStyle/>
+          <a:p>
+            <a:pPr algn="ctr"/>
+          </a:p>
+        </p:txBody>
+      </p:sp>
+      <p:sp>
+        <p:nvSpPr>
+          <p:cNvPr id="16" name="Oval 15"/>
+          <p:cNvSpPr/>
+          <p:nvPr/>
+        </p:nvSpPr>
+        <p:spPr>
+          <a:xfrm>
+            <a:off x="7543800" y="2029967"/>
+            <a:ext cx="137160" cy="137160"/>
+          </a:xfrm>
+          <a:prstGeom prst="ellipse">
             <a:avLst/>
           </a:prstGeom>
           <a:solidFill>
@@ -4605,25 +4909,25 @@
       </p:sp>
       <p:sp>
         <p:nvSpPr>
-          <p:cNvPr id="10" name="Rectangle 9"/>
+          <p:cNvPr id="17" name="Rounded Rectangle 16"/>
           <p:cNvSpPr/>
           <p:nvPr/>
         </p:nvSpPr>
         <p:spPr>
           <a:xfrm>
-            <a:off x="1417319" y="3438144"/>
-            <a:ext cx="3246120" cy="228600"/>
-          </a:xfrm>
-          <a:prstGeom prst="rect">
-            <a:avLst/>
+            <a:off x="8101583" y="1975104"/>
+            <a:ext cx="3154680" cy="310896"/>
+          </a:xfrm>
+          <a:prstGeom prst="roundRect">
+            <a:avLst>
+              <a:gd name="adj" fmla="val 50000"/>
+            </a:avLst>
           </a:prstGeom>
           <a:solidFill>
             <a:srgbClr val="EEF3F0"/>
           </a:solidFill>
-          <a:ln w="9525">
-            <a:solidFill>
-              <a:srgbClr val="DCE3DD"/>
-            </a:solidFill>
+          <a:ln>
+            <a:noFill/>
           </a:ln>
           <a:effectLst/>
         </p:spPr>
@@ -4651,25 +4955,119 @@
       </p:sp>
       <p:sp>
         <p:nvSpPr>
-          <p:cNvPr id="11" name="Rectangle 10"/>
+          <p:cNvPr id="18" name="TextBox 17"/>
+          <p:cNvSpPr txBox="1"/>
+          <p:nvPr/>
+        </p:nvSpPr>
+        <p:spPr>
+          <a:xfrm>
+            <a:off x="8101583" y="1975104"/>
+            <a:ext cx="3154680" cy="310896"/>
+          </a:xfrm>
+          <a:prstGeom prst="rect">
+            <a:avLst/>
+          </a:prstGeom>
+          <a:noFill/>
+        </p:spPr>
+        <p:txBody>
+          <a:bodyPr wrap="square" anchor="ctr" lIns="0" rIns="0" tIns="0" bIns="0">
+            <a:spAutoFit/>
+          </a:bodyPr>
+          <a:lstStyle/>
+          <a:p>
+            <a:pPr algn="ctr"/>
+            <a:r>
+              <a:rPr sz="1050" b="0" i="0">
+                <a:solidFill>
+                  <a:srgbClr val="68736D"/>
+                </a:solidFill>
+                <a:latin typeface="Calibri"/>
+              </a:rPr>
+              <a:t>racelytics · ваш дашборд</a:t>
+            </a:r>
+          </a:p>
+        </p:txBody>
+      </p:sp>
+      <p:pic>
+        <p:nvPicPr>
+          <p:cNvPr id="19" name="Picture 18" descr="compare_cumulative.png"/>
+          <p:cNvPicPr>
+            <a:picLocks noChangeAspect="1"/>
+          </p:cNvPicPr>
+          <p:nvPr/>
+        </p:nvPicPr>
+        <p:blipFill>
+          <a:blip r:embed="rId2"/>
+          <a:stretch>
+            <a:fillRect/>
+          </a:stretch>
+        </p:blipFill>
+        <p:spPr>
+          <a:xfrm>
+            <a:off x="7503958" y="2459736"/>
+            <a:ext cx="3298371" cy="1847088"/>
+          </a:xfrm>
+          <a:prstGeom prst="rect">
+            <a:avLst/>
+          </a:prstGeom>
+        </p:spPr>
+      </p:pic>
+      <p:sp>
+        <p:nvSpPr>
+          <p:cNvPr id="20" name="TextBox 19"/>
+          <p:cNvSpPr txBox="1"/>
+          <p:nvPr/>
+        </p:nvSpPr>
+        <p:spPr>
+          <a:xfrm>
+            <a:off x="5500116" y="2743200"/>
+            <a:ext cx="1188720" cy="822960"/>
+          </a:xfrm>
+          <a:prstGeom prst="rect">
+            <a:avLst/>
+          </a:prstGeom>
+          <a:noFill/>
+        </p:spPr>
+        <p:txBody>
+          <a:bodyPr wrap="square" anchor="ctr" lIns="0" rIns="0" tIns="0" bIns="0">
+            <a:spAutoFit/>
+          </a:bodyPr>
+          <a:lstStyle/>
+          <a:p>
+            <a:pPr algn="ctr"/>
+            <a:r>
+              <a:rPr sz="4200" b="1" i="0">
+                <a:solidFill>
+                  <a:srgbClr val="D69E2E"/>
+                </a:solidFill>
+                <a:latin typeface="Trebuchet MS"/>
+              </a:rPr>
+              <a:t>→</a:t>
+            </a:r>
+          </a:p>
+        </p:txBody>
+      </p:sp>
+      <p:sp>
+        <p:nvSpPr>
+          <p:cNvPr id="21" name="Rounded Rectangle 20"/>
           <p:cNvSpPr/>
           <p:nvPr/>
         </p:nvSpPr>
         <p:spPr>
           <a:xfrm>
-            <a:off x="1417319" y="3685031"/>
-            <a:ext cx="3246120" cy="228600"/>
-          </a:xfrm>
-          <a:prstGeom prst="rect">
-            <a:avLst/>
+            <a:off x="453999" y="4754880"/>
+            <a:ext cx="3456432" cy="603504"/>
+          </a:xfrm>
+          <a:prstGeom prst="roundRect">
+            <a:avLst>
+              <a:gd name="adj" fmla="val 50000"/>
+            </a:avLst>
           </a:prstGeom>
           <a:solidFill>
-            <a:srgbClr val="FFFFFF"/>
+            <a:srgbClr val="ECF3F0"/>
           </a:solidFill>
-          <a:ln w="9525">
-            <a:solidFill>
-              <a:srgbClr val="DCE3DD"/>
-            </a:solidFill>
+          <a:ln>
+            <a:noFill/>
           </a:ln>
           <a:effectLst/>
         </p:spPr>
@@ -4697,65 +5095,17 @@
       </p:sp>
       <p:sp>
         <p:nvSpPr>
-          <p:cNvPr id="12" name="Rectangle 11"/>
+          <p:cNvPr id="22" name="Oval 21"/>
           <p:cNvSpPr/>
           <p:nvPr/>
         </p:nvSpPr>
         <p:spPr>
           <a:xfrm>
-            <a:off x="1417319" y="3931920"/>
-            <a:ext cx="3246120" cy="228600"/>
-          </a:xfrm>
-          <a:prstGeom prst="rect">
-            <a:avLst/>
-          </a:prstGeom>
-          <a:solidFill>
-            <a:srgbClr val="EEF3F0"/>
-          </a:solidFill>
-          <a:ln w="9525">
-            <a:solidFill>
-              <a:srgbClr val="DCE3DD"/>
-            </a:solidFill>
-          </a:ln>
-          <a:effectLst/>
-        </p:spPr>
-        <p:style>
-          <a:lnRef idx="1">
-            <a:schemeClr val="accent1"/>
-          </a:lnRef>
-          <a:fillRef idx="3">
-            <a:schemeClr val="accent1"/>
-          </a:fillRef>
-          <a:effectRef idx="2">
-            <a:schemeClr val="accent1"/>
-          </a:effectRef>
-          <a:fontRef idx="minor">
-            <a:schemeClr val="lt1"/>
-          </a:fontRef>
-        </p:style>
-        <p:txBody>
-          <a:bodyPr rtlCol="0" anchor="ctr"/>
-          <a:lstStyle/>
-          <a:p>
-            <a:pPr algn="ctr"/>
-          </a:p>
-        </p:txBody>
-      </p:sp>
-      <p:sp>
-        <p:nvSpPr>
-          <p:cNvPr id="13" name="Rounded Rectangle 12"/>
-          <p:cNvSpPr/>
-          <p:nvPr/>
-        </p:nvSpPr>
-        <p:spPr>
-          <a:xfrm>
-            <a:off x="7159752" y="1874519"/>
-            <a:ext cx="3977639" cy="2331720"/>
-          </a:xfrm>
-          <a:prstGeom prst="roundRect">
-            <a:avLst>
-              <a:gd name="adj" fmla="val 5000"/>
-            </a:avLst>
+            <a:off x="746607" y="4965192"/>
+            <a:ext cx="182880" cy="182880"/>
+          </a:xfrm>
+          <a:prstGeom prst="ellipse">
+            <a:avLst/>
           </a:prstGeom>
           <a:solidFill>
             <a:srgbClr val="0F766E"/>
@@ -4789,189 +5139,14 @@
       </p:sp>
       <p:sp>
         <p:nvSpPr>
-          <p:cNvPr id="14" name="TextBox 13"/>
+          <p:cNvPr id="23" name="TextBox 22"/>
           <p:cNvSpPr txBox="1"/>
           <p:nvPr/>
         </p:nvSpPr>
         <p:spPr>
           <a:xfrm>
-            <a:off x="7525512" y="2167127"/>
-            <a:ext cx="3246120" cy="457200"/>
-          </a:xfrm>
-          <a:prstGeom prst="rect">
-            <a:avLst/>
-          </a:prstGeom>
-          <a:noFill/>
-        </p:spPr>
-        <p:txBody>
-          <a:bodyPr wrap="square" anchor="t" lIns="0" rIns="0" tIns="0" bIns="0">
-            <a:spAutoFit/>
-          </a:bodyPr>
-          <a:lstStyle/>
-          <a:p>
-            <a:pPr algn="l"/>
-            <a:r>
-              <a:rPr sz="1900" b="1" i="0">
-                <a:solidFill>
-                  <a:srgbClr val="FFFFFF"/>
-                </a:solidFill>
-                <a:latin typeface="Trebuchet MS"/>
-              </a:rPr>
-              <a:t>Racelytics</a:t>
-            </a:r>
-          </a:p>
-        </p:txBody>
-      </p:sp>
-      <p:sp>
-        <p:nvSpPr>
-          <p:cNvPr id="15" name="TextBox 14"/>
-          <p:cNvSpPr txBox="1"/>
-          <p:nvPr/>
-        </p:nvSpPr>
-        <p:spPr>
-          <a:xfrm>
-            <a:off x="7525512" y="2642615"/>
-            <a:ext cx="3246120" cy="320040"/>
-          </a:xfrm>
-          <a:prstGeom prst="rect">
-            <a:avLst/>
-          </a:prstGeom>
-          <a:noFill/>
-        </p:spPr>
-        <p:txBody>
-          <a:bodyPr wrap="square" anchor="t" lIns="0" rIns="0" tIns="0" bIns="0">
-            <a:spAutoFit/>
-          </a:bodyPr>
-          <a:lstStyle/>
-          <a:p>
-            <a:pPr algn="l"/>
-            <a:r>
-              <a:rPr sz="1300" b="0" i="0">
-                <a:solidFill>
-                  <a:srgbClr val="D9EFE9"/>
-                </a:solidFill>
-                <a:latin typeface="Calibri"/>
-              </a:rPr>
-              <a:t>готовый дашборд в браузере</a:t>
-            </a:r>
-          </a:p>
-        </p:txBody>
-      </p:sp>
-      <p:sp>
-        <p:nvSpPr>
-          <p:cNvPr id="16" name="Rounded Rectangle 15"/>
-          <p:cNvSpPr/>
-          <p:nvPr/>
-        </p:nvSpPr>
-        <p:spPr>
-          <a:xfrm>
-            <a:off x="7525512" y="3063239"/>
-            <a:ext cx="3246120" cy="914399"/>
-          </a:xfrm>
-          <a:prstGeom prst="roundRect">
-            <a:avLst>
-              <a:gd name="adj" fmla="val 5000"/>
-            </a:avLst>
-          </a:prstGeom>
-          <a:solidFill>
-            <a:srgbClr val="FFFFFF"/>
-          </a:solidFill>
-          <a:ln>
-            <a:noFill/>
-          </a:ln>
-          <a:effectLst/>
-        </p:spPr>
-        <p:style>
-          <a:lnRef idx="1">
-            <a:schemeClr val="accent1"/>
-          </a:lnRef>
-          <a:fillRef idx="3">
-            <a:schemeClr val="accent1"/>
-          </a:fillRef>
-          <a:effectRef idx="2">
-            <a:schemeClr val="accent1"/>
-          </a:effectRef>
-          <a:fontRef idx="minor">
-            <a:schemeClr val="lt1"/>
-          </a:fontRef>
-        </p:style>
-        <p:txBody>
-          <a:bodyPr rtlCol="0" anchor="ctr"/>
-          <a:lstStyle/>
-          <a:p>
-            <a:pPr algn="ctr"/>
-          </a:p>
-        </p:txBody>
-      </p:sp>
-      <p:pic>
-        <p:nvPicPr>
-          <p:cNvPr id="17" name="Picture 16" descr="cumulativeChart_c.png"/>
-          <p:cNvPicPr>
-            <a:picLocks noChangeAspect="1"/>
-          </p:cNvPicPr>
-          <p:nvPr/>
-        </p:nvPicPr>
-        <p:blipFill>
-          <a:blip r:embed="rId2"/>
-          <a:stretch>
-            <a:fillRect/>
-          </a:stretch>
-        </p:blipFill>
-        <p:spPr>
-          <a:xfrm>
-            <a:off x="8666879" y="3154679"/>
-            <a:ext cx="963385" cy="731519"/>
-          </a:xfrm>
-          <a:prstGeom prst="rect">
-            <a:avLst/>
-          </a:prstGeom>
-        </p:spPr>
-      </p:pic>
-      <p:sp>
-        <p:nvSpPr>
-          <p:cNvPr id="18" name="TextBox 17"/>
-          <p:cNvSpPr txBox="1"/>
-          <p:nvPr/>
-        </p:nvSpPr>
-        <p:spPr>
-          <a:xfrm>
-            <a:off x="5271516" y="2377439"/>
-            <a:ext cx="1645920" cy="365760"/>
-          </a:xfrm>
-          <a:prstGeom prst="rect">
-            <a:avLst/>
-          </a:prstGeom>
-          <a:noFill/>
-        </p:spPr>
-        <p:txBody>
-          <a:bodyPr wrap="square" anchor="t" lIns="0" rIns="0" tIns="0" bIns="0">
-            <a:spAutoFit/>
-          </a:bodyPr>
-          <a:lstStyle/>
-          <a:p>
-            <a:pPr algn="ctr"/>
-            <a:r>
-              <a:rPr sz="1300" b="1" i="0">
-                <a:solidFill>
-                  <a:srgbClr val="68736D"/>
-                </a:solidFill>
-                <a:latin typeface="Calibri"/>
-              </a:rPr>
-              <a:t>ссылка</a:t>
-            </a:r>
-          </a:p>
-        </p:txBody>
-      </p:sp>
-      <p:sp>
-        <p:nvSpPr>
-          <p:cNvPr id="19" name="TextBox 18"/>
-          <p:cNvSpPr txBox="1"/>
-          <p:nvPr/>
-        </p:nvSpPr>
-        <p:spPr>
-          <a:xfrm>
-            <a:off x="5271516" y="2743200"/>
-            <a:ext cx="1645920" cy="822960"/>
+            <a:off x="1057503" y="4754880"/>
+            <a:ext cx="2679191" cy="603504"/>
           </a:xfrm>
           <a:prstGeom prst="rect">
             <a:avLst/>
@@ -4984,28 +5159,28 @@
           </a:bodyPr>
           <a:lstStyle/>
           <a:p>
-            <a:pPr algn="ctr"/>
-            <a:r>
-              <a:rPr sz="4600" b="1" i="0">
-                <a:solidFill>
-                  <a:srgbClr val="D69E2E"/>
-                </a:solidFill>
-                <a:latin typeface="Trebuchet MS"/>
+            <a:pPr algn="l"/>
+            <a:r>
+              <a:rPr sz="1350" b="1" i="0">
+                <a:solidFill>
+                  <a:srgbClr val="0B5751"/>
+                </a:solidFill>
+                <a:latin typeface="Calibri"/>
               </a:rPr>
-              <a:t>→</a:t>
-            </a:r>
-          </a:p>
-        </p:txBody>
-      </p:sp>
-      <p:sp>
-        <p:nvSpPr>
-          <p:cNvPr id="20" name="Rounded Rectangle 19"/>
+              <a:t>Ничего не устанавливать</a:t>
+            </a:r>
+          </a:p>
+        </p:txBody>
+      </p:sp>
+      <p:sp>
+        <p:nvSpPr>
+          <p:cNvPr id="24" name="Rounded Rectangle 23"/>
           <p:cNvSpPr/>
           <p:nvPr/>
         </p:nvSpPr>
         <p:spPr>
           <a:xfrm>
-            <a:off x="453999" y="4617720"/>
+            <a:off x="4367631" y="4754880"/>
             <a:ext cx="3456432" cy="603504"/>
           </a:xfrm>
           <a:prstGeom prst="roundRect">
@@ -5045,13 +5220,13 @@
       </p:sp>
       <p:sp>
         <p:nvSpPr>
-          <p:cNvPr id="21" name="Oval 20"/>
+          <p:cNvPr id="25" name="Oval 24"/>
           <p:cNvSpPr/>
           <p:nvPr/>
         </p:nvSpPr>
         <p:spPr>
           <a:xfrm>
-            <a:off x="746607" y="4828032"/>
+            <a:off x="4660239" y="4965192"/>
             <a:ext cx="182880" cy="182880"/>
           </a:xfrm>
           <a:prstGeom prst="ellipse">
@@ -5089,13 +5264,13 @@
       </p:sp>
       <p:sp>
         <p:nvSpPr>
-          <p:cNvPr id="22" name="TextBox 21"/>
+          <p:cNvPr id="26" name="TextBox 25"/>
           <p:cNvSpPr txBox="1"/>
           <p:nvPr/>
         </p:nvSpPr>
         <p:spPr>
           <a:xfrm>
-            <a:off x="1057503" y="4617720"/>
+            <a:off x="4971135" y="4754880"/>
             <a:ext cx="2679191" cy="603504"/>
           </a:xfrm>
           <a:prstGeom prst="rect">
@@ -5117,20 +5292,20 @@
                 </a:solidFill>
                 <a:latin typeface="Calibri"/>
               </a:rPr>
-              <a:t>Ничего не устанавливать</a:t>
-            </a:r>
-          </a:p>
-        </p:txBody>
-      </p:sp>
-      <p:sp>
-        <p:nvSpPr>
-          <p:cNvPr id="23" name="Rounded Rectangle 22"/>
+              <a:t>Без аккаунтов и паролей</a:t>
+            </a:r>
+          </a:p>
+        </p:txBody>
+      </p:sp>
+      <p:sp>
+        <p:nvSpPr>
+          <p:cNvPr id="27" name="Rounded Rectangle 26"/>
           <p:cNvSpPr/>
           <p:nvPr/>
         </p:nvSpPr>
         <p:spPr>
           <a:xfrm>
-            <a:off x="4367631" y="4617720"/>
+            <a:off x="8281263" y="4754880"/>
             <a:ext cx="3456432" cy="603504"/>
           </a:xfrm>
           <a:prstGeom prst="roundRect">
@@ -5170,13 +5345,13 @@
       </p:sp>
       <p:sp>
         <p:nvSpPr>
-          <p:cNvPr id="24" name="Oval 23"/>
+          <p:cNvPr id="28" name="Oval 27"/>
           <p:cNvSpPr/>
           <p:nvPr/>
         </p:nvSpPr>
         <p:spPr>
           <a:xfrm>
-            <a:off x="4660239" y="4828032"/>
+            <a:off x="8573871" y="4965192"/>
             <a:ext cx="182880" cy="182880"/>
           </a:xfrm>
           <a:prstGeom prst="ellipse">
@@ -5214,13 +5389,13 @@
       </p:sp>
       <p:sp>
         <p:nvSpPr>
-          <p:cNvPr id="25" name="TextBox 24"/>
+          <p:cNvPr id="29" name="TextBox 28"/>
           <p:cNvSpPr txBox="1"/>
           <p:nvPr/>
         </p:nvSpPr>
         <p:spPr>
           <a:xfrm>
-            <a:off x="4971135" y="4617720"/>
+            <a:off x="8884767" y="4754880"/>
             <a:ext cx="2679191" cy="603504"/>
           </a:xfrm>
           <a:prstGeom prst="rect">
@@ -5242,111 +5417,21 @@
                 </a:solidFill>
                 <a:latin typeface="Calibri"/>
               </a:rPr>
-              <a:t>Без аккаунтов и паролей</a:t>
-            </a:r>
-          </a:p>
-        </p:txBody>
-      </p:sp>
-      <p:sp>
-        <p:nvSpPr>
-          <p:cNvPr id="26" name="Rounded Rectangle 25"/>
-          <p:cNvSpPr/>
-          <p:nvPr/>
-        </p:nvSpPr>
-        <p:spPr>
-          <a:xfrm>
-            <a:off x="8281263" y="4617720"/>
-            <a:ext cx="3456432" cy="603504"/>
-          </a:xfrm>
-          <a:prstGeom prst="roundRect">
-            <a:avLst>
-              <a:gd name="adj" fmla="val 50000"/>
-            </a:avLst>
-          </a:prstGeom>
-          <a:solidFill>
-            <a:srgbClr val="ECF3F0"/>
-          </a:solidFill>
-          <a:ln>
-            <a:noFill/>
-          </a:ln>
-          <a:effectLst/>
-        </p:spPr>
-        <p:style>
-          <a:lnRef idx="1">
-            <a:schemeClr val="accent1"/>
-          </a:lnRef>
-          <a:fillRef idx="3">
-            <a:schemeClr val="accent1"/>
-          </a:fillRef>
-          <a:effectRef idx="2">
-            <a:schemeClr val="accent1"/>
-          </a:effectRef>
-          <a:fontRef idx="minor">
-            <a:schemeClr val="lt1"/>
-          </a:fontRef>
-        </p:style>
-        <p:txBody>
-          <a:bodyPr rtlCol="0" anchor="ctr"/>
-          <a:lstStyle/>
-          <a:p>
-            <a:pPr algn="ctr"/>
-          </a:p>
-        </p:txBody>
-      </p:sp>
-      <p:sp>
-        <p:nvSpPr>
-          <p:cNvPr id="27" name="Oval 26"/>
-          <p:cNvSpPr/>
-          <p:nvPr/>
-        </p:nvSpPr>
-        <p:spPr>
-          <a:xfrm>
-            <a:off x="8573871" y="4828032"/>
-            <a:ext cx="182880" cy="182880"/>
-          </a:xfrm>
-          <a:prstGeom prst="ellipse">
-            <a:avLst/>
-          </a:prstGeom>
-          <a:solidFill>
-            <a:srgbClr val="0F766E"/>
-          </a:solidFill>
-          <a:ln>
-            <a:noFill/>
-          </a:ln>
-          <a:effectLst/>
-        </p:spPr>
-        <p:style>
-          <a:lnRef idx="1">
-            <a:schemeClr val="accent1"/>
-          </a:lnRef>
-          <a:fillRef idx="3">
-            <a:schemeClr val="accent1"/>
-          </a:fillRef>
-          <a:effectRef idx="2">
-            <a:schemeClr val="accent1"/>
-          </a:effectRef>
-          <a:fontRef idx="minor">
-            <a:schemeClr val="lt1"/>
-          </a:fontRef>
-        </p:style>
-        <p:txBody>
-          <a:bodyPr rtlCol="0" anchor="ctr"/>
-          <a:lstStyle/>
-          <a:p>
-            <a:pPr algn="ctr"/>
-          </a:p>
-        </p:txBody>
-      </p:sp>
-      <p:sp>
-        <p:nvSpPr>
-          <p:cNvPr id="28" name="TextBox 27"/>
+              <a:t>Данные остаются в вашей таблице</a:t>
+            </a:r>
+          </a:p>
+        </p:txBody>
+      </p:sp>
+      <p:sp>
+        <p:nvSpPr>
+          <p:cNvPr id="30" name="TextBox 29"/>
           <p:cNvSpPr txBox="1"/>
           <p:nvPr/>
         </p:nvSpPr>
         <p:spPr>
           <a:xfrm>
-            <a:off x="8884767" y="4617720"/>
-            <a:ext cx="2679191" cy="603504"/>
+            <a:off x="868680" y="5650992"/>
+            <a:ext cx="10881360" cy="548640"/>
           </a:xfrm>
           <a:prstGeom prst="rect">
             <a:avLst/>
@@ -5359,41 +5444,6 @@
           </a:bodyPr>
           <a:lstStyle/>
           <a:p>
-            <a:pPr algn="l"/>
-            <a:r>
-              <a:rPr sz="1350" b="1" i="0">
-                <a:solidFill>
-                  <a:srgbClr val="0B5751"/>
-                </a:solidFill>
-                <a:latin typeface="Calibri"/>
-              </a:rPr>
-              <a:t>Данные остаются в вашей таблице</a:t>
-            </a:r>
-          </a:p>
-        </p:txBody>
-      </p:sp>
-      <p:sp>
-        <p:nvSpPr>
-          <p:cNvPr id="29" name="TextBox 28"/>
-          <p:cNvSpPr txBox="1"/>
-          <p:nvPr/>
-        </p:nvSpPr>
-        <p:spPr>
-          <a:xfrm>
-            <a:off x="868680" y="5532120"/>
-            <a:ext cx="10881360" cy="640080"/>
-          </a:xfrm>
-          <a:prstGeom prst="rect">
-            <a:avLst/>
-          </a:prstGeom>
-          <a:noFill/>
-        </p:spPr>
-        <p:txBody>
-          <a:bodyPr wrap="square" anchor="ctr" lIns="0" rIns="0" tIns="0" bIns="0">
-            <a:spAutoFit/>
-          </a:bodyPr>
-          <a:lstStyle/>
-          <a:p>
             <a:pPr algn="ctr"/>
             <a:r>
               <a:rPr sz="1500" b="1" i="0">
@@ -5411,7 +5461,7 @@
                 </a:solidFill>
                 <a:latin typeface="Calibri"/>
               </a:rPr>
-              <a:t>Правите таблицу — дашборд показывает свежие данные.</a:t>
+              <a:t>Данные всегда берутся прямо из вашей таблицы.</a:t>
             </a:r>
           </a:p>
         </p:txBody>
@@ -5566,7 +5616,7 @@
         <p:spPr>
           <a:xfrm>
             <a:off x="868680" y="1042416"/>
-            <a:ext cx="10881360" cy="457200"/>
+            <a:ext cx="10927080" cy="457200"/>
           </a:xfrm>
           <a:prstGeom prst="rect">
             <a:avLst/>
@@ -5646,7 +5696,7 @@
       </p:sp>
       <p:pic>
         <p:nvPicPr>
-          <p:cNvPr id="7" name="Picture 6" descr="cumulativeChart.png"/>
+          <p:cNvPr id="7" name="Picture 6" descr="overview_women.png"/>
           <p:cNvPicPr>
             <a:picLocks noChangeAspect="1"/>
           </p:cNvPicPr>
@@ -5660,8 +5710,8 @@
         </p:blipFill>
         <p:spPr>
           <a:xfrm>
-            <a:off x="777240" y="2049502"/>
-            <a:ext cx="6355080" cy="3581954"/>
+            <a:off x="777240" y="1971771"/>
+            <a:ext cx="6355080" cy="3554536"/>
           </a:xfrm>
           <a:prstGeom prst="rect">
             <a:avLst/>
@@ -5676,7 +5726,7 @@
         </p:nvSpPr>
         <p:spPr>
           <a:xfrm>
-            <a:off x="777240" y="5541264"/>
+            <a:off x="777240" y="5522976"/>
             <a:ext cx="6355080" cy="274320"/>
           </a:xfrm>
           <a:prstGeom prst="rect">
@@ -5860,7 +5910,7 @@
                 </a:solidFill>
                 <a:latin typeface="Calibri"/>
               </a:rPr>
-              <a:t>Женщины 3.6 км · Лыжероллерный круг 1.2 км</a:t>
+              <a:t>Ж 3.6 км · Лыжероллерный круг 1.2 км</a:t>
             </a:r>
           </a:p>
         </p:txBody>
@@ -6550,7 +6600,7 @@
                 </a:solidFill>
                 <a:latin typeface="Trebuchet MS"/>
               </a:rPr>
-              <a:t>Сравнивайте, кого нужно</a:t>
+              <a:t>Сравнивайте: суммарно и по кругам</a:t>
             </a:r>
           </a:p>
         </p:txBody>
@@ -6564,7 +6614,7 @@
         <p:spPr>
           <a:xfrm>
             <a:off x="868680" y="1042416"/>
-            <a:ext cx="10881360" cy="457200"/>
+            <a:ext cx="10927080" cy="457200"/>
           </a:xfrm>
           <a:prstGeom prst="rect">
             <a:avLst/>
@@ -6589,7 +6639,7 @@
                 </a:solidFill>
                 <a:latin typeface="Calibri"/>
               </a:rPr>
-              <a:t>Отметьте участников звёздочкой — на графике останутся только они, а рядом появится таблица разницы по кругам.</a:t>
+              <a:t>Отметьте участников звёздочкой — останутся только они. Видно и общий отрыв, и каждый круг отдельно.</a:t>
             </a:r>
           </a:p>
         </p:txBody>
@@ -6602,8 +6652,8 @@
         </p:nvSpPr>
         <p:spPr>
           <a:xfrm>
-            <a:off x="566928" y="1810512"/>
-            <a:ext cx="5806440" cy="3108960"/>
+            <a:off x="566928" y="1645920"/>
+            <a:ext cx="5340096" cy="3200400"/>
           </a:xfrm>
           <a:prstGeom prst="roundRect">
             <a:avLst>
@@ -6650,8 +6700,8 @@
         </p:nvSpPr>
         <p:spPr>
           <a:xfrm>
-            <a:off x="841247" y="1993392"/>
-            <a:ext cx="5257800" cy="320040"/>
+            <a:off x="877824" y="1828800"/>
+            <a:ext cx="4718304" cy="310896"/>
           </a:xfrm>
           <a:prstGeom prst="rect">
             <a:avLst/>
@@ -6666,20 +6716,59 @@
           <a:p>
             <a:pPr algn="l"/>
             <a:r>
-              <a:rPr sz="1300" b="1" i="0">
-                <a:solidFill>
-                  <a:srgbClr val="17201C"/>
+              <a:rPr sz="1600" b="1" i="0">
+                <a:solidFill>
+                  <a:srgbClr val="0F766E"/>
                 </a:solidFill>
                 <a:latin typeface="Trebuchet MS"/>
               </a:rPr>
-              <a:t>На графике — только отмеченные</a:t>
+              <a:t>Суммарное время</a:t>
+            </a:r>
+          </a:p>
+        </p:txBody>
+      </p:sp>
+      <p:sp>
+        <p:nvSpPr>
+          <p:cNvPr id="8" name="TextBox 7"/>
+          <p:cNvSpPr txBox="1"/>
+          <p:nvPr/>
+        </p:nvSpPr>
+        <p:spPr>
+          <a:xfrm>
+            <a:off x="877824" y="2157984"/>
+            <a:ext cx="4718304" cy="329184"/>
+          </a:xfrm>
+          <a:prstGeom prst="rect">
+            <a:avLst/>
+          </a:prstGeom>
+          <a:noFill/>
+        </p:spPr>
+        <p:txBody>
+          <a:bodyPr wrap="square" anchor="t" lIns="0" rIns="0" tIns="0" bIns="0">
+            <a:spAutoFit/>
+          </a:bodyPr>
+          <a:lstStyle/>
+          <a:p>
+            <a:pPr algn="l">
+              <a:lnSpc>
+                <a:spcPct val="105000"/>
+              </a:lnSpc>
+            </a:pPr>
+            <a:r>
+              <a:rPr sz="1200" b="0" i="0">
+                <a:solidFill>
+                  <a:srgbClr val="434D47"/>
+                </a:solidFill>
+                <a:latin typeface="Calibri"/>
+              </a:rPr>
+              <a:t>Растущий отрыв — насколько и где оторвался лидер.</a:t>
             </a:r>
           </a:p>
         </p:txBody>
       </p:sp>
       <p:pic>
         <p:nvPicPr>
-          <p:cNvPr id="8" name="Picture 7" descr="compare_chart.png"/>
+          <p:cNvPr id="9" name="Picture 8" descr="compare_cumulative.png"/>
           <p:cNvPicPr>
             <a:picLocks noChangeAspect="1"/>
           </p:cNvPicPr>
@@ -6693,8 +6782,8 @@
         </p:blipFill>
         <p:spPr>
           <a:xfrm>
-            <a:off x="1363762" y="2377440"/>
-            <a:ext cx="4212771" cy="2359152"/>
+            <a:off x="1359190" y="2560320"/>
+            <a:ext cx="3755571" cy="2103120"/>
           </a:xfrm>
           <a:prstGeom prst="rect">
             <a:avLst/>
@@ -6703,14 +6792,14 @@
       </p:pic>
       <p:sp>
         <p:nvSpPr>
-          <p:cNvPr id="9" name="Rounded Rectangle 8"/>
+          <p:cNvPr id="10" name="Rounded Rectangle 9"/>
           <p:cNvSpPr/>
           <p:nvPr/>
         </p:nvSpPr>
         <p:spPr>
           <a:xfrm>
-            <a:off x="6537960" y="1810512"/>
-            <a:ext cx="5084064" cy="3108960"/>
+            <a:off x="6281928" y="1645920"/>
+            <a:ext cx="5340096" cy="3200400"/>
           </a:xfrm>
           <a:prstGeom prst="roundRect">
             <a:avLst>
@@ -6751,14 +6840,49 @@
       </p:sp>
       <p:sp>
         <p:nvSpPr>
-          <p:cNvPr id="10" name="TextBox 9"/>
+          <p:cNvPr id="11" name="TextBox 10"/>
           <p:cNvSpPr txBox="1"/>
           <p:nvPr/>
         </p:nvSpPr>
         <p:spPr>
           <a:xfrm>
-            <a:off x="6830568" y="1993392"/>
-            <a:ext cx="4498848" cy="548640"/>
+            <a:off x="6592824" y="1828800"/>
+            <a:ext cx="4718304" cy="310896"/>
+          </a:xfrm>
+          <a:prstGeom prst="rect">
+            <a:avLst/>
+          </a:prstGeom>
+          <a:noFill/>
+        </p:spPr>
+        <p:txBody>
+          <a:bodyPr wrap="square" anchor="t" lIns="0" rIns="0" tIns="0" bIns="0">
+            <a:spAutoFit/>
+          </a:bodyPr>
+          <a:lstStyle/>
+          <a:p>
+            <a:pPr algn="l"/>
+            <a:r>
+              <a:rPr sz="1600" b="1" i="0">
+                <a:solidFill>
+                  <a:srgbClr val="0F766E"/>
+                </a:solidFill>
+                <a:latin typeface="Trebuchet MS"/>
+              </a:rPr>
+              <a:t>Круги</a:t>
+            </a:r>
+          </a:p>
+        </p:txBody>
+      </p:sp>
+      <p:sp>
+        <p:nvSpPr>
+          <p:cNvPr id="12" name="TextBox 11"/>
+          <p:cNvSpPr txBox="1"/>
+          <p:nvPr/>
+        </p:nvSpPr>
+        <p:spPr>
+          <a:xfrm>
+            <a:off x="6592824" y="2157984"/>
+            <a:ext cx="4718304" cy="329184"/>
           </a:xfrm>
           <a:prstGeom prst="rect">
             <a:avLst/>
@@ -6777,725 +6901,50 @@
               </a:lnSpc>
             </a:pPr>
             <a:r>
-              <a:rPr sz="1400" b="1" i="0">
-                <a:solidFill>
-                  <a:srgbClr val="17201C"/>
-                </a:solidFill>
-                <a:latin typeface="Trebuchet MS"/>
-              </a:rPr>
-              <a:t>Разница по кругам</a:t>
-            </a:r>
-          </a:p>
-          <a:p>
-            <a:pPr algn="l">
-              <a:lnSpc>
-                <a:spcPct val="105000"/>
-              </a:lnSpc>
-            </a:pPr>
-            <a:r>
-              <a:rPr sz="1100" b="0" i="0">
-                <a:solidFill>
-                  <a:srgbClr val="68736D"/>
+              <a:rPr sz="1200" b="0" i="0">
+                <a:solidFill>
+                  <a:srgbClr val="434D47"/>
                 </a:solidFill>
                 <a:latin typeface="Calibri"/>
               </a:rPr>
-              <a:t>нарастающий отрыв к лидеру выбранных</a:t>
-            </a:r>
-          </a:p>
-        </p:txBody>
-      </p:sp>
-      <p:graphicFrame>
-        <p:nvGraphicFramePr>
-          <p:cNvPr id="11" name="Table 10"/>
-          <p:cNvGraphicFramePr>
-            <a:graphicFrameLocks noGrp="1"/>
-          </p:cNvGraphicFramePr>
-          <p:nvPr/>
-        </p:nvGraphicFramePr>
-        <p:xfrm>
-          <a:off x="6812280" y="2770632"/>
-          <a:ext cx="4535424" cy="1874519"/>
-        </p:xfrm>
-        <a:graphic>
-          <a:graphicData uri="http://schemas.openxmlformats.org/drawingml/2006/table">
-            <a:tbl>
-              <a:tblPr>
-                <a:tableStyleId>{5C22544A-7EE6-4342-B048-85BDC9FD1C3A}</a:tableStyleId>
-              </a:tblPr>
-              <a:tblGrid>
-                <a:gridCol w="1691640"/>
-                <a:gridCol w="473964"/>
-                <a:gridCol w="473964"/>
-                <a:gridCol w="473964"/>
-                <a:gridCol w="473964"/>
-                <a:gridCol w="473964"/>
-                <a:gridCol w="473964"/>
-              </a:tblGrid>
-              <a:tr h="468629">
-                <a:tc>
-                  <a:txBody>
-                    <a:bodyPr/>
-                    <a:lstStyle/>
-                    <a:p>
-                      <a:pPr algn="l"/>
-                      <a:r>
-                        <a:rPr sz="1000" b="1">
-                          <a:solidFill>
-                            <a:srgbClr val="FFFFFF"/>
-                          </a:solidFill>
-                          <a:latin typeface="Calibri"/>
-                        </a:rPr>
-                        <a:t>Участник</a:t>
-                      </a:r>
-                    </a:p>
-                  </a:txBody>
-                  <a:tcPr marL="50800" marR="50800" marT="25400" marB="25400" anchor="ctr">
-                    <a:solidFill>
-                      <a:srgbClr val="0F766E"/>
-                    </a:solidFill>
-                  </a:tcPr>
-                </a:tc>
-                <a:tc>
-                  <a:txBody>
-                    <a:bodyPr/>
-                    <a:lstStyle/>
-                    <a:p>
-                      <a:pPr algn="ctr"/>
-                      <a:r>
-                        <a:rPr sz="1050" b="1">
-                          <a:solidFill>
-                            <a:srgbClr val="FFFFFF"/>
-                          </a:solidFill>
-                          <a:latin typeface="Calibri"/>
-                        </a:rPr>
-                        <a:t>1</a:t>
-                      </a:r>
-                    </a:p>
-                  </a:txBody>
-                  <a:tcPr marL="50800" marR="50800" marT="25400" marB="25400" anchor="ctr">
-                    <a:solidFill>
-                      <a:srgbClr val="0F766E"/>
-                    </a:solidFill>
-                  </a:tcPr>
-                </a:tc>
-                <a:tc>
-                  <a:txBody>
-                    <a:bodyPr/>
-                    <a:lstStyle/>
-                    <a:p>
-                      <a:pPr algn="ctr"/>
-                      <a:r>
-                        <a:rPr sz="1050" b="1">
-                          <a:solidFill>
-                            <a:srgbClr val="FFFFFF"/>
-                          </a:solidFill>
-                          <a:latin typeface="Calibri"/>
-                        </a:rPr>
-                        <a:t>2</a:t>
-                      </a:r>
-                    </a:p>
-                  </a:txBody>
-                  <a:tcPr marL="50800" marR="50800" marT="25400" marB="25400" anchor="ctr">
-                    <a:solidFill>
-                      <a:srgbClr val="0F766E"/>
-                    </a:solidFill>
-                  </a:tcPr>
-                </a:tc>
-                <a:tc>
-                  <a:txBody>
-                    <a:bodyPr/>
-                    <a:lstStyle/>
-                    <a:p>
-                      <a:pPr algn="ctr"/>
-                      <a:r>
-                        <a:rPr sz="1050" b="1">
-                          <a:solidFill>
-                            <a:srgbClr val="FFFFFF"/>
-                          </a:solidFill>
-                          <a:latin typeface="Calibri"/>
-                        </a:rPr>
-                        <a:t>3</a:t>
-                      </a:r>
-                    </a:p>
-                  </a:txBody>
-                  <a:tcPr marL="50800" marR="50800" marT="25400" marB="25400" anchor="ctr">
-                    <a:solidFill>
-                      <a:srgbClr val="0F766E"/>
-                    </a:solidFill>
-                  </a:tcPr>
-                </a:tc>
-                <a:tc>
-                  <a:txBody>
-                    <a:bodyPr/>
-                    <a:lstStyle/>
-                    <a:p>
-                      <a:pPr algn="ctr"/>
-                      <a:r>
-                        <a:rPr sz="1050" b="1">
-                          <a:solidFill>
-                            <a:srgbClr val="FFFFFF"/>
-                          </a:solidFill>
-                          <a:latin typeface="Calibri"/>
-                        </a:rPr>
-                        <a:t>4</a:t>
-                      </a:r>
-                    </a:p>
-                  </a:txBody>
-                  <a:tcPr marL="50800" marR="50800" marT="25400" marB="25400" anchor="ctr">
-                    <a:solidFill>
-                      <a:srgbClr val="0F766E"/>
-                    </a:solidFill>
-                  </a:tcPr>
-                </a:tc>
-                <a:tc>
-                  <a:txBody>
-                    <a:bodyPr/>
-                    <a:lstStyle/>
-                    <a:p>
-                      <a:pPr algn="ctr"/>
-                      <a:r>
-                        <a:rPr sz="1050" b="1">
-                          <a:solidFill>
-                            <a:srgbClr val="FFFFFF"/>
-                          </a:solidFill>
-                          <a:latin typeface="Calibri"/>
-                        </a:rPr>
-                        <a:t>5</a:t>
-                      </a:r>
-                    </a:p>
-                  </a:txBody>
-                  <a:tcPr marL="50800" marR="50800" marT="25400" marB="25400" anchor="ctr">
-                    <a:solidFill>
-                      <a:srgbClr val="0F766E"/>
-                    </a:solidFill>
-                  </a:tcPr>
-                </a:tc>
-                <a:tc>
-                  <a:txBody>
-                    <a:bodyPr/>
-                    <a:lstStyle/>
-                    <a:p>
-                      <a:pPr algn="ctr"/>
-                      <a:r>
-                        <a:rPr sz="1050" b="1">
-                          <a:solidFill>
-                            <a:srgbClr val="FFFFFF"/>
-                          </a:solidFill>
-                          <a:latin typeface="Calibri"/>
-                        </a:rPr>
-                        <a:t>6</a:t>
-                      </a:r>
-                    </a:p>
-                  </a:txBody>
-                  <a:tcPr marL="50800" marR="50800" marT="25400" marB="25400" anchor="ctr">
-                    <a:solidFill>
-                      <a:srgbClr val="0F766E"/>
-                    </a:solidFill>
-                  </a:tcPr>
-                </a:tc>
-              </a:tr>
-              <a:tr h="468629">
-                <a:tc>
-                  <a:txBody>
-                    <a:bodyPr/>
-                    <a:lstStyle/>
-                    <a:p>
-                      <a:pPr algn="l"/>
-                      <a:r>
-                        <a:rPr sz="1000" b="1">
-                          <a:solidFill>
-                            <a:srgbClr val="17201C"/>
-                          </a:solidFill>
-                          <a:latin typeface="Calibri"/>
-                        </a:rPr>
-                        <a:t>#47 Королёв Н.</a:t>
-                      </a:r>
-                    </a:p>
-                  </a:txBody>
-                  <a:tcPr marL="50800" marR="50800" marT="25400" marB="25400" anchor="ctr">
-                    <a:solidFill>
-                      <a:srgbClr val="FFFFFF"/>
-                    </a:solidFill>
-                  </a:tcPr>
-                </a:tc>
-                <a:tc>
-                  <a:txBody>
-                    <a:bodyPr/>
-                    <a:lstStyle/>
-                    <a:p>
-                      <a:pPr algn="ctr"/>
-                      <a:r>
-                        <a:rPr sz="1050" b="1">
-                          <a:solidFill>
-                            <a:srgbClr val="68736D"/>
-                          </a:solidFill>
-                          <a:latin typeface="Calibri"/>
-                        </a:rPr>
-                        <a:t>0:00</a:t>
-                      </a:r>
-                    </a:p>
-                  </a:txBody>
-                  <a:tcPr marL="50800" marR="50800" marT="25400" marB="25400" anchor="ctr">
-                    <a:solidFill>
-                      <a:srgbClr val="FFFFFF"/>
-                    </a:solidFill>
-                  </a:tcPr>
-                </a:tc>
-                <a:tc>
-                  <a:txBody>
-                    <a:bodyPr/>
-                    <a:lstStyle/>
-                    <a:p>
-                      <a:pPr algn="ctr"/>
-                      <a:r>
-                        <a:rPr sz="1050" b="1">
-                          <a:solidFill>
-                            <a:srgbClr val="68736D"/>
-                          </a:solidFill>
-                          <a:latin typeface="Calibri"/>
-                        </a:rPr>
-                        <a:t>0:00</a:t>
-                      </a:r>
-                    </a:p>
-                  </a:txBody>
-                  <a:tcPr marL="50800" marR="50800" marT="25400" marB="25400" anchor="ctr">
-                    <a:solidFill>
-                      <a:srgbClr val="FFFFFF"/>
-                    </a:solidFill>
-                  </a:tcPr>
-                </a:tc>
-                <a:tc>
-                  <a:txBody>
-                    <a:bodyPr/>
-                    <a:lstStyle/>
-                    <a:p>
-                      <a:pPr algn="ctr"/>
-                      <a:r>
-                        <a:rPr sz="1050" b="1">
-                          <a:solidFill>
-                            <a:srgbClr val="68736D"/>
-                          </a:solidFill>
-                          <a:latin typeface="Calibri"/>
-                        </a:rPr>
-                        <a:t>0:00</a:t>
-                      </a:r>
-                    </a:p>
-                  </a:txBody>
-                  <a:tcPr marL="50800" marR="50800" marT="25400" marB="25400" anchor="ctr">
-                    <a:solidFill>
-                      <a:srgbClr val="FFFFFF"/>
-                    </a:solidFill>
-                  </a:tcPr>
-                </a:tc>
-                <a:tc>
-                  <a:txBody>
-                    <a:bodyPr/>
-                    <a:lstStyle/>
-                    <a:p>
-                      <a:pPr algn="ctr"/>
-                      <a:r>
-                        <a:rPr sz="1050" b="1">
-                          <a:solidFill>
-                            <a:srgbClr val="68736D"/>
-                          </a:solidFill>
-                          <a:latin typeface="Calibri"/>
-                        </a:rPr>
-                        <a:t>0:00</a:t>
-                      </a:r>
-                    </a:p>
-                  </a:txBody>
-                  <a:tcPr marL="50800" marR="50800" marT="25400" marB="25400" anchor="ctr">
-                    <a:solidFill>
-                      <a:srgbClr val="FFFFFF"/>
-                    </a:solidFill>
-                  </a:tcPr>
-                </a:tc>
-                <a:tc>
-                  <a:txBody>
-                    <a:bodyPr/>
-                    <a:lstStyle/>
-                    <a:p>
-                      <a:pPr algn="ctr"/>
-                      <a:r>
-                        <a:rPr sz="1050" b="1">
-                          <a:solidFill>
-                            <a:srgbClr val="68736D"/>
-                          </a:solidFill>
-                          <a:latin typeface="Calibri"/>
-                        </a:rPr>
-                        <a:t>0:00</a:t>
-                      </a:r>
-                    </a:p>
-                  </a:txBody>
-                  <a:tcPr marL="50800" marR="50800" marT="25400" marB="25400" anchor="ctr">
-                    <a:solidFill>
-                      <a:srgbClr val="FFFFFF"/>
-                    </a:solidFill>
-                  </a:tcPr>
-                </a:tc>
-                <a:tc>
-                  <a:txBody>
-                    <a:bodyPr/>
-                    <a:lstStyle/>
-                    <a:p>
-                      <a:pPr algn="ctr"/>
-                      <a:r>
-                        <a:rPr sz="1050" b="1">
-                          <a:solidFill>
-                            <a:srgbClr val="68736D"/>
-                          </a:solidFill>
-                          <a:latin typeface="Calibri"/>
-                        </a:rPr>
-                        <a:t>0:00</a:t>
-                      </a:r>
-                    </a:p>
-                  </a:txBody>
-                  <a:tcPr marL="50800" marR="50800" marT="25400" marB="25400" anchor="ctr">
-                    <a:solidFill>
-                      <a:srgbClr val="FFFFFF"/>
-                    </a:solidFill>
-                  </a:tcPr>
-                </a:tc>
-              </a:tr>
-              <a:tr h="468629">
-                <a:tc>
-                  <a:txBody>
-                    <a:bodyPr/>
-                    <a:lstStyle/>
-                    <a:p>
-                      <a:pPr algn="l"/>
-                      <a:r>
-                        <a:rPr sz="1000" b="1">
-                          <a:solidFill>
-                            <a:srgbClr val="17201C"/>
-                          </a:solidFill>
-                          <a:latin typeface="Calibri"/>
-                        </a:rPr>
-                        <a:t>#26 Чупров А.</a:t>
-                      </a:r>
-                    </a:p>
-                  </a:txBody>
-                  <a:tcPr marL="50800" marR="50800" marT="25400" marB="25400" anchor="ctr">
-                    <a:solidFill>
-                      <a:srgbClr val="FFFFFF"/>
-                    </a:solidFill>
-                  </a:tcPr>
-                </a:tc>
-                <a:tc>
-                  <a:txBody>
-                    <a:bodyPr/>
-                    <a:lstStyle/>
-                    <a:p>
-                      <a:pPr algn="ctr"/>
-                      <a:r>
-                        <a:rPr sz="1050" b="1">
-                          <a:solidFill>
-                            <a:srgbClr val="B3261E"/>
-                          </a:solidFill>
-                          <a:latin typeface="Calibri"/>
-                        </a:rPr>
-                        <a:t>+0:24</a:t>
-                      </a:r>
-                    </a:p>
-                  </a:txBody>
-                  <a:tcPr marL="50800" marR="50800" marT="25400" marB="25400" anchor="ctr">
-                    <a:solidFill>
-                      <a:srgbClr val="FFFFFF"/>
-                    </a:solidFill>
-                  </a:tcPr>
-                </a:tc>
-                <a:tc>
-                  <a:txBody>
-                    <a:bodyPr/>
-                    <a:lstStyle/>
-                    <a:p>
-                      <a:pPr algn="ctr"/>
-                      <a:r>
-                        <a:rPr sz="1050" b="1">
-                          <a:solidFill>
-                            <a:srgbClr val="B3261E"/>
-                          </a:solidFill>
-                          <a:latin typeface="Calibri"/>
-                        </a:rPr>
-                        <a:t>+1:01</a:t>
-                      </a:r>
-                    </a:p>
-                  </a:txBody>
-                  <a:tcPr marL="50800" marR="50800" marT="25400" marB="25400" anchor="ctr">
-                    <a:solidFill>
-                      <a:srgbClr val="FFFFFF"/>
-                    </a:solidFill>
-                  </a:tcPr>
-                </a:tc>
-                <a:tc>
-                  <a:txBody>
-                    <a:bodyPr/>
-                    <a:lstStyle/>
-                    <a:p>
-                      <a:pPr algn="ctr"/>
-                      <a:r>
-                        <a:rPr sz="1050" b="1">
-                          <a:solidFill>
-                            <a:srgbClr val="B3261E"/>
-                          </a:solidFill>
-                          <a:latin typeface="Calibri"/>
-                        </a:rPr>
-                        <a:t>+1:43</a:t>
-                      </a:r>
-                    </a:p>
-                  </a:txBody>
-                  <a:tcPr marL="50800" marR="50800" marT="25400" marB="25400" anchor="ctr">
-                    <a:solidFill>
-                      <a:srgbClr val="FFFFFF"/>
-                    </a:solidFill>
-                  </a:tcPr>
-                </a:tc>
-                <a:tc>
-                  <a:txBody>
-                    <a:bodyPr/>
-                    <a:lstStyle/>
-                    <a:p>
-                      <a:pPr algn="ctr"/>
-                      <a:r>
-                        <a:rPr sz="1050" b="1">
-                          <a:solidFill>
-                            <a:srgbClr val="B3261E"/>
-                          </a:solidFill>
-                          <a:latin typeface="Calibri"/>
-                        </a:rPr>
-                        <a:t>+2:30</a:t>
-                      </a:r>
-                    </a:p>
-                  </a:txBody>
-                  <a:tcPr marL="50800" marR="50800" marT="25400" marB="25400" anchor="ctr">
-                    <a:solidFill>
-                      <a:srgbClr val="FFFFFF"/>
-                    </a:solidFill>
-                  </a:tcPr>
-                </a:tc>
-                <a:tc>
-                  <a:txBody>
-                    <a:bodyPr/>
-                    <a:lstStyle/>
-                    <a:p>
-                      <a:pPr algn="ctr"/>
-                      <a:r>
-                        <a:rPr sz="1050" b="1">
-                          <a:solidFill>
-                            <a:srgbClr val="B3261E"/>
-                          </a:solidFill>
-                          <a:latin typeface="Calibri"/>
-                        </a:rPr>
-                        <a:t>+3:02</a:t>
-                      </a:r>
-                    </a:p>
-                  </a:txBody>
-                  <a:tcPr marL="50800" marR="50800" marT="25400" marB="25400" anchor="ctr">
-                    <a:solidFill>
-                      <a:srgbClr val="FFFFFF"/>
-                    </a:solidFill>
-                  </a:tcPr>
-                </a:tc>
-                <a:tc>
-                  <a:txBody>
-                    <a:bodyPr/>
-                    <a:lstStyle/>
-                    <a:p>
-                      <a:pPr algn="ctr"/>
-                      <a:r>
-                        <a:rPr sz="1050" b="1">
-                          <a:solidFill>
-                            <a:srgbClr val="B3261E"/>
-                          </a:solidFill>
-                          <a:latin typeface="Calibri"/>
-                        </a:rPr>
-                        <a:t>+3:32</a:t>
-                      </a:r>
-                    </a:p>
-                  </a:txBody>
-                  <a:tcPr marL="50800" marR="50800" marT="25400" marB="25400" anchor="ctr">
-                    <a:solidFill>
-                      <a:srgbClr val="FFFFFF"/>
-                    </a:solidFill>
-                  </a:tcPr>
-                </a:tc>
-              </a:tr>
-              <a:tr h="468632">
-                <a:tc>
-                  <a:txBody>
-                    <a:bodyPr/>
-                    <a:lstStyle/>
-                    <a:p>
-                      <a:pPr algn="l"/>
-                      <a:r>
-                        <a:rPr sz="1000" b="1">
-                          <a:solidFill>
-                            <a:srgbClr val="17201C"/>
-                          </a:solidFill>
-                          <a:latin typeface="Calibri"/>
-                        </a:rPr>
-                        <a:t>#49 Вотолевский А.</a:t>
-                      </a:r>
-                    </a:p>
-                  </a:txBody>
-                  <a:tcPr marL="50800" marR="50800" marT="25400" marB="25400" anchor="ctr">
-                    <a:solidFill>
-                      <a:srgbClr val="FFFFFF"/>
-                    </a:solidFill>
-                  </a:tcPr>
-                </a:tc>
-                <a:tc>
-                  <a:txBody>
-                    <a:bodyPr/>
-                    <a:lstStyle/>
-                    <a:p>
-                      <a:pPr algn="ctr"/>
-                      <a:r>
-                        <a:rPr sz="1050" b="1">
-                          <a:solidFill>
-                            <a:srgbClr val="B3261E"/>
-                          </a:solidFill>
-                          <a:latin typeface="Calibri"/>
-                        </a:rPr>
-                        <a:t>+1:58</a:t>
-                      </a:r>
-                    </a:p>
-                  </a:txBody>
-                  <a:tcPr marL="50800" marR="50800" marT="25400" marB="25400" anchor="ctr">
-                    <a:solidFill>
-                      <a:srgbClr val="FFFFFF"/>
-                    </a:solidFill>
-                  </a:tcPr>
-                </a:tc>
-                <a:tc>
-                  <a:txBody>
-                    <a:bodyPr/>
-                    <a:lstStyle/>
-                    <a:p>
-                      <a:pPr algn="ctr"/>
-                      <a:r>
-                        <a:rPr sz="1050" b="1">
-                          <a:solidFill>
-                            <a:srgbClr val="B3261E"/>
-                          </a:solidFill>
-                          <a:latin typeface="Calibri"/>
-                        </a:rPr>
-                        <a:t>+3:58</a:t>
-                      </a:r>
-                    </a:p>
-                  </a:txBody>
-                  <a:tcPr marL="50800" marR="50800" marT="25400" marB="25400" anchor="ctr">
-                    <a:solidFill>
-                      <a:srgbClr val="FFFFFF"/>
-                    </a:solidFill>
-                  </a:tcPr>
-                </a:tc>
-                <a:tc>
-                  <a:txBody>
-                    <a:bodyPr/>
-                    <a:lstStyle/>
-                    <a:p>
-                      <a:pPr algn="ctr"/>
-                      <a:r>
-                        <a:rPr sz="1050" b="1">
-                          <a:solidFill>
-                            <a:srgbClr val="B3261E"/>
-                          </a:solidFill>
-                          <a:latin typeface="Calibri"/>
-                        </a:rPr>
-                        <a:t>+6:01</a:t>
-                      </a:r>
-                    </a:p>
-                  </a:txBody>
-                  <a:tcPr marL="50800" marR="50800" marT="25400" marB="25400" anchor="ctr">
-                    <a:solidFill>
-                      <a:srgbClr val="FFFFFF"/>
-                    </a:solidFill>
-                  </a:tcPr>
-                </a:tc>
-                <a:tc>
-                  <a:txBody>
-                    <a:bodyPr/>
-                    <a:lstStyle/>
-                    <a:p>
-                      <a:pPr algn="ctr"/>
-                      <a:r>
-                        <a:rPr sz="1050" b="1">
-                          <a:solidFill>
-                            <a:srgbClr val="B3261E"/>
-                          </a:solidFill>
-                          <a:latin typeface="Calibri"/>
-                        </a:rPr>
-                        <a:t>+8:25</a:t>
-                      </a:r>
-                    </a:p>
-                  </a:txBody>
-                  <a:tcPr marL="50800" marR="50800" marT="25400" marB="25400" anchor="ctr">
-                    <a:solidFill>
-                      <a:srgbClr val="FFFFFF"/>
-                    </a:solidFill>
-                  </a:tcPr>
-                </a:tc>
-                <a:tc>
-                  <a:txBody>
-                    <a:bodyPr/>
-                    <a:lstStyle/>
-                    <a:p>
-                      <a:pPr algn="ctr"/>
-                      <a:r>
-                        <a:rPr sz="1050" b="1">
-                          <a:solidFill>
-                            <a:srgbClr val="B3261E"/>
-                          </a:solidFill>
-                          <a:latin typeface="Calibri"/>
-                        </a:rPr>
-                        <a:t>+10:54</a:t>
-                      </a:r>
-                    </a:p>
-                  </a:txBody>
-                  <a:tcPr marL="50800" marR="50800" marT="25400" marB="25400" anchor="ctr">
-                    <a:solidFill>
-                      <a:srgbClr val="FFFFFF"/>
-                    </a:solidFill>
-                  </a:tcPr>
-                </a:tc>
-                <a:tc>
-                  <a:txBody>
-                    <a:bodyPr/>
-                    <a:lstStyle/>
-                    <a:p>
-                      <a:pPr algn="ctr"/>
-                      <a:r>
-                        <a:rPr sz="1050" b="1">
-                          <a:solidFill>
-                            <a:srgbClr val="B3261E"/>
-                          </a:solidFill>
-                          <a:latin typeface="Calibri"/>
-                        </a:rPr>
-                        <a:t>+13:31</a:t>
-                      </a:r>
-                    </a:p>
-                  </a:txBody>
-                  <a:tcPr marL="50800" marR="50800" marT="25400" marB="25400" anchor="ctr">
-                    <a:solidFill>
-                      <a:srgbClr val="FFFFFF"/>
-                    </a:solidFill>
-                  </a:tcPr>
-                </a:tc>
-              </a:tr>
-            </a:tbl>
-          </a:graphicData>
-        </a:graphic>
-      </p:graphicFrame>
-      <p:sp>
-        <p:nvSpPr>
-          <p:cNvPr id="12" name="Rounded Rectangle 11"/>
+              <a:t>Темп по кругам — кто держал ровно, кто встал, кто ускорился.</a:t>
+            </a:r>
+          </a:p>
+        </p:txBody>
+      </p:sp>
+      <p:pic>
+        <p:nvPicPr>
+          <p:cNvPr id="13" name="Picture 12" descr="compare_laps.png"/>
+          <p:cNvPicPr>
+            <a:picLocks noChangeAspect="1"/>
+          </p:cNvPicPr>
+          <p:nvPr/>
+        </p:nvPicPr>
+        <p:blipFill>
+          <a:blip r:embed="rId3"/>
+          <a:stretch>
+            <a:fillRect/>
+          </a:stretch>
+        </p:blipFill>
+        <p:spPr>
+          <a:xfrm>
+            <a:off x="7074190" y="2560320"/>
+            <a:ext cx="3755571" cy="2103120"/>
+          </a:xfrm>
+          <a:prstGeom prst="rect">
+            <a:avLst/>
+          </a:prstGeom>
+        </p:spPr>
+      </p:pic>
+      <p:sp>
+        <p:nvSpPr>
+          <p:cNvPr id="14" name="Rounded Rectangle 13"/>
           <p:cNvSpPr/>
           <p:nvPr/>
         </p:nvSpPr>
         <p:spPr>
           <a:xfrm>
-            <a:off x="348843" y="5193792"/>
+            <a:off x="348843" y="5029200"/>
             <a:ext cx="3611880" cy="868680"/>
           </a:xfrm>
           <a:prstGeom prst="roundRect">
@@ -7537,13 +6986,13 @@
       </p:sp>
       <p:sp>
         <p:nvSpPr>
-          <p:cNvPr id="13" name="Oval 12"/>
+          <p:cNvPr id="15" name="Oval 14"/>
           <p:cNvSpPr/>
           <p:nvPr/>
         </p:nvSpPr>
         <p:spPr>
           <a:xfrm>
-            <a:off x="623163" y="5522976"/>
+            <a:off x="623163" y="5358384"/>
             <a:ext cx="201168" cy="201168"/>
           </a:xfrm>
           <a:prstGeom prst="ellipse">
@@ -7581,14 +7030,14 @@
       </p:sp>
       <p:sp>
         <p:nvSpPr>
-          <p:cNvPr id="14" name="TextBox 13"/>
+          <p:cNvPr id="16" name="TextBox 15"/>
           <p:cNvSpPr txBox="1"/>
           <p:nvPr/>
         </p:nvSpPr>
         <p:spPr>
           <a:xfrm>
-            <a:off x="943203" y="5340096"/>
-            <a:ext cx="2834640" cy="292608"/>
+            <a:off x="952347" y="5202936"/>
+            <a:ext cx="2788920" cy="292608"/>
           </a:xfrm>
           <a:prstGeom prst="rect">
             <a:avLst/>
@@ -7603,27 +7052,27 @@
           <a:p>
             <a:pPr algn="l"/>
             <a:r>
-              <a:rPr sz="1400" b="1" i="0">
+              <a:rPr sz="1350" b="1" i="0">
                 <a:solidFill>
                   <a:srgbClr val="17201C"/>
                 </a:solidFill>
                 <a:latin typeface="Trebuchet MS"/>
               </a:rPr>
-              <a:t>Суммарное время</a:t>
-            </a:r>
-          </a:p>
-        </p:txBody>
-      </p:sp>
-      <p:sp>
-        <p:nvSpPr>
-          <p:cNvPr id="15" name="TextBox 14"/>
+              <a:t>#47 Королёв Н.</a:t>
+            </a:r>
+          </a:p>
+        </p:txBody>
+      </p:sp>
+      <p:sp>
+        <p:nvSpPr>
+          <p:cNvPr id="17" name="TextBox 16"/>
           <p:cNvSpPr txBox="1"/>
           <p:nvPr/>
         </p:nvSpPr>
         <p:spPr>
           <a:xfrm>
-            <a:off x="943203" y="5650992"/>
-            <a:ext cx="2834640" cy="320040"/>
+            <a:off x="952347" y="5513832"/>
+            <a:ext cx="2788920" cy="292608"/>
           </a:xfrm>
           <a:prstGeom prst="rect">
             <a:avLst/>
@@ -7644,20 +7093,20 @@
                 </a:solidFill>
                 <a:latin typeface="Calibri"/>
               </a:rPr>
-              <a:t>нарастающий отрыв по кругам</a:t>
-            </a:r>
-          </a:p>
-        </p:txBody>
-      </p:sp>
-      <p:sp>
-        <p:nvSpPr>
-          <p:cNvPr id="16" name="Rounded Rectangle 15"/>
+              <a:t>лидер, ровный темп</a:t>
+            </a:r>
+          </a:p>
+        </p:txBody>
+      </p:sp>
+      <p:sp>
+        <p:nvSpPr>
+          <p:cNvPr id="18" name="Rounded Rectangle 17"/>
           <p:cNvSpPr/>
           <p:nvPr/>
         </p:nvSpPr>
         <p:spPr>
           <a:xfrm>
-            <a:off x="4289907" y="5193792"/>
+            <a:off x="4289907" y="5029200"/>
             <a:ext cx="3611880" cy="868680"/>
           </a:xfrm>
           <a:prstGeom prst="roundRect">
@@ -7699,20 +7148,20 @@
       </p:sp>
       <p:sp>
         <p:nvSpPr>
-          <p:cNvPr id="17" name="Oval 16"/>
+          <p:cNvPr id="19" name="Oval 18"/>
           <p:cNvSpPr/>
           <p:nvPr/>
         </p:nvSpPr>
         <p:spPr>
           <a:xfrm>
-            <a:off x="4564227" y="5522976"/>
+            <a:off x="4564227" y="5358384"/>
             <a:ext cx="201168" cy="201168"/>
           </a:xfrm>
           <a:prstGeom prst="ellipse">
             <a:avLst/>
           </a:prstGeom>
           <a:solidFill>
-            <a:srgbClr val="0F766E"/>
+            <a:srgbClr val="B3261E"/>
           </a:solidFill>
           <a:ln>
             <a:noFill/>
@@ -7743,14 +7192,14 @@
       </p:sp>
       <p:sp>
         <p:nvSpPr>
-          <p:cNvPr id="18" name="TextBox 17"/>
+          <p:cNvPr id="20" name="TextBox 19"/>
           <p:cNvSpPr txBox="1"/>
           <p:nvPr/>
         </p:nvSpPr>
         <p:spPr>
           <a:xfrm>
-            <a:off x="4884267" y="5340096"/>
-            <a:ext cx="2834640" cy="292608"/>
+            <a:off x="4893411" y="5202936"/>
+            <a:ext cx="2788920" cy="292608"/>
           </a:xfrm>
           <a:prstGeom prst="rect">
             <a:avLst/>
@@ -7765,27 +7214,27 @@
           <a:p>
             <a:pPr algn="l"/>
             <a:r>
-              <a:rPr sz="1400" b="1" i="0">
+              <a:rPr sz="1350" b="1" i="0">
                 <a:solidFill>
                   <a:srgbClr val="17201C"/>
                 </a:solidFill>
                 <a:latin typeface="Trebuchet MS"/>
               </a:rPr>
-              <a:t>Круги</a:t>
-            </a:r>
-          </a:p>
-        </p:txBody>
-      </p:sp>
-      <p:sp>
-        <p:nvSpPr>
-          <p:cNvPr id="19" name="TextBox 18"/>
+              <a:t>#26 Чупров А.</a:t>
+            </a:r>
+          </a:p>
+        </p:txBody>
+      </p:sp>
+      <p:sp>
+        <p:nvSpPr>
+          <p:cNvPr id="21" name="TextBox 20"/>
           <p:cNvSpPr txBox="1"/>
           <p:nvPr/>
         </p:nvSpPr>
         <p:spPr>
           <a:xfrm>
-            <a:off x="4884267" y="5650992"/>
-            <a:ext cx="2834640" cy="320040"/>
+            <a:off x="4893411" y="5513832"/>
+            <a:ext cx="2788920" cy="292608"/>
           </a:xfrm>
           <a:prstGeom prst="rect">
             <a:avLst/>
@@ -7806,20 +7255,20 @@
                 </a:solidFill>
                 <a:latin typeface="Calibri"/>
               </a:rPr>
-              <a:t>длительность каждого круга</a:t>
-            </a:r>
-          </a:p>
-        </p:txBody>
-      </p:sp>
-      <p:sp>
-        <p:nvSpPr>
-          <p:cNvPr id="20" name="Rounded Rectangle 19"/>
+              <a:t>просел в середине</a:t>
+            </a:r>
+          </a:p>
+        </p:txBody>
+      </p:sp>
+      <p:sp>
+        <p:nvSpPr>
+          <p:cNvPr id="22" name="Rounded Rectangle 21"/>
           <p:cNvSpPr/>
           <p:nvPr/>
         </p:nvSpPr>
         <p:spPr>
           <a:xfrm>
-            <a:off x="8230971" y="5193792"/>
+            <a:off x="8230971" y="5029200"/>
             <a:ext cx="3611880" cy="868680"/>
           </a:xfrm>
           <a:prstGeom prst="roundRect">
@@ -7861,20 +7310,20 @@
       </p:sp>
       <p:sp>
         <p:nvSpPr>
-          <p:cNvPr id="21" name="Oval 20"/>
+          <p:cNvPr id="23" name="Oval 22"/>
           <p:cNvSpPr/>
           <p:nvPr/>
         </p:nvSpPr>
         <p:spPr>
           <a:xfrm>
-            <a:off x="8505291" y="5522976"/>
+            <a:off x="8505291" y="5358384"/>
             <a:ext cx="201168" cy="201168"/>
           </a:xfrm>
           <a:prstGeom prst="ellipse">
             <a:avLst/>
           </a:prstGeom>
           <a:solidFill>
-            <a:srgbClr val="0F766E"/>
+            <a:srgbClr val="D69E2E"/>
           </a:solidFill>
           <a:ln>
             <a:noFill/>
@@ -7905,14 +7354,14 @@
       </p:sp>
       <p:sp>
         <p:nvSpPr>
-          <p:cNvPr id="22" name="TextBox 21"/>
+          <p:cNvPr id="24" name="TextBox 23"/>
           <p:cNvSpPr txBox="1"/>
           <p:nvPr/>
         </p:nvSpPr>
         <p:spPr>
           <a:xfrm>
-            <a:off x="8825331" y="5340096"/>
-            <a:ext cx="2834640" cy="292608"/>
+            <a:off x="8834475" y="5202936"/>
+            <a:ext cx="2788920" cy="292608"/>
           </a:xfrm>
           <a:prstGeom prst="rect">
             <a:avLst/>
@@ -7927,27 +7376,27 @@
           <a:p>
             <a:pPr algn="l"/>
             <a:r>
-              <a:rPr sz="1400" b="1" i="0">
+              <a:rPr sz="1350" b="1" i="0">
                 <a:solidFill>
                   <a:srgbClr val="17201C"/>
                 </a:solidFill>
                 <a:latin typeface="Trebuchet MS"/>
               </a:rPr>
-              <a:t>Позиция</a:t>
-            </a:r>
-          </a:p>
-        </p:txBody>
-      </p:sp>
-      <p:sp>
-        <p:nvSpPr>
-          <p:cNvPr id="23" name="TextBox 22"/>
+              <a:t>#49 Вотолевский А.</a:t>
+            </a:r>
+          </a:p>
+        </p:txBody>
+      </p:sp>
+      <p:sp>
+        <p:nvSpPr>
+          <p:cNvPr id="25" name="TextBox 24"/>
           <p:cNvSpPr txBox="1"/>
           <p:nvPr/>
         </p:nvSpPr>
         <p:spPr>
           <a:xfrm>
-            <a:off x="8825331" y="5650992"/>
-            <a:ext cx="2834640" cy="320040"/>
+            <a:off x="8834475" y="5513832"/>
+            <a:ext cx="2788920" cy="292608"/>
           </a:xfrm>
           <a:prstGeom prst="rect">
             <a:avLst/>
@@ -7968,7 +7417,7 @@
                 </a:solidFill>
                 <a:latin typeface="Calibri"/>
               </a:rPr>
-              <a:t>как менялось место в зачёте</a:t>
+              <a:t>слабел к финишу</a:t>
             </a:r>
           </a:p>
         </p:txBody>
@@ -8123,7 +7572,7 @@
         <p:spPr>
           <a:xfrm>
             <a:off x="868680" y="1042416"/>
-            <a:ext cx="10881360" cy="457200"/>
+            <a:ext cx="10927080" cy="457200"/>
           </a:xfrm>
           <a:prstGeom prst="rect">
             <a:avLst/>
@@ -8906,7 +8355,7 @@
                 </a:solidFill>
                 <a:latin typeface="Calibri"/>
               </a:rPr>
-              <a:t>По ходу гонки </a:t>
+              <a:t>Обновили таблицу — </a:t>
             </a:r>
             <a:r>
               <a:rPr sz="1500" b="1" i="0">
@@ -8915,7 +8364,7 @@
                 </a:solidFill>
                 <a:latin typeface="Trebuchet MS"/>
               </a:rPr>
-              <a:t>дописываете круги прямо в таблицу</a:t>
+              <a:t>перезагрузите дашборд</a:t>
             </a:r>
             <a:r>
               <a:rPr sz="1500" b="0" i="0">
@@ -8924,7 +8373,7 @@
                 </a:solidFill>
                 <a:latin typeface="Calibri"/>
               </a:rPr>
-              <a:t> — дашборд обновляется сам.</a:t>
+              <a:t>, и он покажет свежие данные.</a:t>
             </a:r>
           </a:p>
         </p:txBody>

</xml_diff>